<commit_message>
MC slide: restore the discussed structure (fixed-vs-random setup + 90/80 x independent/correlated table + precision)
- Held-fixed vs drawn-at-random setup boxes
- Results table: 90% (prec 92%) / 80% (prec 84%) model, assumptions independent
  vs correlated, with 0%-loss row and 90% CI ranges (56% universe)
- Read + regime caveat + precision definition line
</commit_message>
<xml_diff>
--- a/reports/Biotech_Catalyst_Strategy_Deck.pptx
+++ b/reports/Biotech_Catalyst_Strategy_Deck.pptx
@@ -692,7 +692,7 @@
           <a:p>
             <a:r>
               <a:rPr lang="en-US" dirty="0"/>
-              <a:t>This is the uncertainty slide - it answers 'your assumptions are guesses, so how fragile is this?' A few of our inputs we genuinely don't know - the borrow rate, how much of the position is actually on loan, the trading cost. So instead of guessing once, we drew them at random and re-ran the whole strategy 500 times. The result: a typical run makes $22M, and 90% of runs land between $18M and $27M, and importantly none of them lose money - even the unlucky 5% still ends around $18M, well above the $10M we started with. So the takeaway on the left: our cost guesses don't make or break it. The catch on the right, and I'll be upfront: this only shuffles the COST assumptions - every run still uses 2016 to 2019 prices, so '0% lose' means in a market like that one, not a guarantee. The model-accuracy question is separate, and that's the next slide - which is the real risk.</a:t>
+              <a:t>This is the uncertainty slide, and it follows a specific structure. First, the setup up top: we HOLD the model accuracy fixed - at 90%, then 80% - and we hold our own design choices fixed, like sizing and timing. What we DRAW AT RANDOM are the four things we genuinely don't know: the borrow rate, utilization, the post-event fade, and trading cost - each over a wide range. Then we re-ran the strategy 500 times. The table: at a 90% model the typical run makes about $22M, with 90% of runs between $18M and $27M; at 80% it's about $19.5M. We draw the assumptions two ways - independently, and correlated, meaning a bad-liquidity regime hits all of them at once - and even correlated it barely moves. Crucially, zero runs lose money. Note the header says 'precision 92%' - that's how often the model's 'success' call is actually right, and it's high because we're at the realistic 56% base rate, which is the next slide. The honest caveat: this only shuffles the cost guesses; every run still uses 2016-2019 prices, so '0% loss' means in a market like that one.</a:t>
             </a:r>
             <a:endParaRPr lang="en-US" dirty="0"/>
           </a:p>
@@ -3332,7 +3332,7 @@
                 <a:ea typeface="Cambria" pitchFamily="34" charset="-122"/>
                 <a:cs typeface="Cambria" pitchFamily="34" charset="-120"/>
               </a:rPr>
-              <a:t>Monte Carlo - how much do our guesses matter?</a:t>
+              <a:t>Monte Carlo - do our assumption-guesses break it?</a:t>
             </a:r>
             <a:endParaRPr lang="en-US" sz="2500" dirty="0"/>
           </a:p>
@@ -3371,7 +3371,7 @@
                 <a:ea typeface="Calibri" pitchFamily="34" charset="-122"/>
                 <a:cs typeface="Calibri" pitchFamily="34" charset="-120"/>
               </a:rPr>
-              <a:t>We don't know the exact borrow rate, utilization, etc. So we rolled the dice 500 times.</a:t>
+              <a:t>Hold model accuracy fixed; roll the uncertain cost assumptions 500 times (56% universe).</a:t>
             </a:r>
             <a:endParaRPr lang="en-US" sz="1250" dirty="0"/>
           </a:p>
@@ -3379,40 +3379,297 @@
       </p:sp>
       <p:sp>
         <p:nvSpPr>
-          <p:cNvPr id="5" name="Text 3"/>
-          <p:cNvSpPr/>
-          <p:nvPr/>
-        </p:nvSpPr>
-        <p:spPr>
-          <a:xfrm>
-            <a:off x="548640" y="1508760"/>
-            <a:ext cx="11064240" cy="457200"/>
-          </a:xfrm>
-          <a:prstGeom prst="rect">
-            <a:avLst/>
-          </a:prstGeom>
-          <a:noFill/>
-          <a:ln/>
-        </p:spPr>
-        <p:txBody>
-          <a:bodyPr wrap="square" rtlCol="0" anchor="ctr"/>
+          <p:cNvPr id="5" name="Shape 3"/>
+          <p:cNvSpPr/>
+          <p:nvPr/>
+        </p:nvSpPr>
+        <p:spPr>
+          <a:xfrm>
+            <a:off x="548640" y="1463040"/>
+            <a:ext cx="5440680" cy="1417320"/>
+          </a:xfrm>
+          <a:prstGeom prst="roundRect">
+            <a:avLst>
+              <a:gd name="adj" fmla="val 5161"/>
+            </a:avLst>
+          </a:prstGeom>
+          <a:solidFill>
+            <a:srgbClr val="F4F6FC"/>
+          </a:solidFill>
+          <a:ln w="12700">
+            <a:solidFill>
+              <a:srgbClr val="E4E6EE"/>
+            </a:solidFill>
+            <a:prstDash val="solid"/>
+          </a:ln>
+        </p:spPr>
+      </p:sp>
+      <p:sp>
+        <p:nvSpPr>
+          <p:cNvPr id="6" name="Text 4"/>
+          <p:cNvSpPr/>
+          <p:nvPr/>
+        </p:nvSpPr>
+        <p:spPr>
+          <a:xfrm>
+            <a:off x="731520" y="1554480"/>
+            <a:ext cx="5029200" cy="274320"/>
+          </a:xfrm>
+          <a:prstGeom prst="rect">
+            <a:avLst/>
+          </a:prstGeom>
+          <a:noFill/>
+          <a:ln/>
+        </p:spPr>
+        <p:txBody>
+          <a:bodyPr wrap="square" lIns="0" tIns="0" rIns="0" bIns="0" rtlCol="0" anchor="ctr"/>
           <a:lstStyle/>
           <a:p>
             <a:pPr indent="0" marL="0">
               <a:buNone/>
             </a:pPr>
             <a:r>
-              <a:rPr lang="en-US" sz="1400" b="1" dirty="0">
-                <a:solidFill>
-                  <a:srgbClr val="1E2761"/>
+              <a:rPr lang="en-US" sz="1100" b="1" spc="100" kern="0" dirty="0">
+                <a:solidFill>
+                  <a:srgbClr val="5B636E"/>
                 </a:solidFill>
                 <a:latin typeface="Calibri" pitchFamily="34" charset="0"/>
                 <a:ea typeface="Calibri" pitchFamily="34" charset="-122"/>
                 <a:cs typeface="Calibri" pitchFamily="34" charset="-120"/>
               </a:rPr>
-              <a:t>We drew the uncertain cost assumptions at random and re-ran the strategy 500 times (56% universe, 90% model):</a:t>
-            </a:r>
-            <a:endParaRPr lang="en-US" sz="1400" dirty="0"/>
+              <a:t>HELD FIXED (the baseline)</a:t>
+            </a:r>
+            <a:endParaRPr lang="en-US" sz="1100" dirty="0"/>
+          </a:p>
+        </p:txBody>
+      </p:sp>
+      <p:sp>
+        <p:nvSpPr>
+          <p:cNvPr id="7" name="Text 5"/>
+          <p:cNvSpPr/>
+          <p:nvPr/>
+        </p:nvSpPr>
+        <p:spPr>
+          <a:xfrm>
+            <a:off x="731520" y="1874520"/>
+            <a:ext cx="5029200" cy="914400"/>
+          </a:xfrm>
+          <a:prstGeom prst="rect">
+            <a:avLst/>
+          </a:prstGeom>
+          <a:noFill/>
+          <a:ln/>
+        </p:spPr>
+        <p:txBody>
+          <a:bodyPr wrap="square" lIns="0" tIns="0" rIns="0" bIns="0" rtlCol="0" anchor="t"/>
+          <a:lstStyle/>
+          <a:p>
+            <a:pPr indent="0" marL="0">
+              <a:lnSpc>
+                <a:spcPct val="115000"/>
+              </a:lnSpc>
+              <a:buNone/>
+            </a:pPr>
+            <a:r>
+              <a:rPr lang="en-US" sz="1250" dirty="0">
+                <a:solidFill>
+                  <a:srgbClr val="27313F"/>
+                </a:solidFill>
+                <a:latin typeface="Calibri" pitchFamily="34" charset="0"/>
+                <a:ea typeface="Calibri" pitchFamily="34" charset="-122"/>
+                <a:cs typeface="Calibri" pitchFamily="34" charset="-120"/>
+              </a:rPr>
+              <a:t>Model accuracy 90% (then 80%)</a:t>
+            </a:r>
+            <a:endParaRPr lang="en-US" sz="1250" dirty="0"/>
+          </a:p>
+          <a:p>
+            <a:pPr indent="0" marL="0">
+              <a:lnSpc>
+                <a:spcPct val="115000"/>
+              </a:lnSpc>
+              <a:buNone/>
+            </a:pPr>
+            <a:r>
+              <a:rPr lang="en-US" sz="1250" dirty="0">
+                <a:solidFill>
+                  <a:srgbClr val="27313F"/>
+                </a:solidFill>
+                <a:latin typeface="Calibri" pitchFamily="34" charset="0"/>
+                <a:ea typeface="Calibri" pitchFamily="34" charset="-122"/>
+                <a:cs typeface="Calibri" pitchFamily="34" charset="-120"/>
+              </a:rPr>
+              <a:t>Position size 5%, ~30 names, timing</a:t>
+            </a:r>
+            <a:endParaRPr lang="en-US" sz="1250" dirty="0"/>
+          </a:p>
+          <a:p>
+            <a:pPr indent="0" marL="0">
+              <a:lnSpc>
+                <a:spcPct val="115000"/>
+              </a:lnSpc>
+              <a:buNone/>
+            </a:pPr>
+            <a:r>
+              <a:rPr lang="en-US" sz="1250" dirty="0">
+                <a:solidFill>
+                  <a:srgbClr val="27313F"/>
+                </a:solidFill>
+                <a:latin typeface="Calibri" pitchFamily="34" charset="0"/>
+                <a:ea typeface="Calibri" pitchFamily="34" charset="-122"/>
+                <a:cs typeface="Calibri" pitchFamily="34" charset="-120"/>
+              </a:rPr>
+              <a:t>(our design choices)</a:t>
+            </a:r>
+            <a:endParaRPr lang="en-US" sz="1250" dirty="0"/>
+          </a:p>
+        </p:txBody>
+      </p:sp>
+      <p:sp>
+        <p:nvSpPr>
+          <p:cNvPr id="8" name="Shape 6"/>
+          <p:cNvSpPr/>
+          <p:nvPr/>
+        </p:nvSpPr>
+        <p:spPr>
+          <a:xfrm>
+            <a:off x="6172200" y="1463040"/>
+            <a:ext cx="5440680" cy="1417320"/>
+          </a:xfrm>
+          <a:prstGeom prst="roundRect">
+            <a:avLst>
+              <a:gd name="adj" fmla="val 5161"/>
+            </a:avLst>
+          </a:prstGeom>
+          <a:solidFill>
+            <a:srgbClr val="F0FAF6"/>
+          </a:solidFill>
+          <a:ln w="12700">
+            <a:solidFill>
+              <a:srgbClr val="02C39A"/>
+            </a:solidFill>
+            <a:prstDash val="solid"/>
+          </a:ln>
+        </p:spPr>
+      </p:sp>
+      <p:sp>
+        <p:nvSpPr>
+          <p:cNvPr id="9" name="Text 7"/>
+          <p:cNvSpPr/>
+          <p:nvPr/>
+        </p:nvSpPr>
+        <p:spPr>
+          <a:xfrm>
+            <a:off x="6355080" y="1554480"/>
+            <a:ext cx="5029200" cy="274320"/>
+          </a:xfrm>
+          <a:prstGeom prst="rect">
+            <a:avLst/>
+          </a:prstGeom>
+          <a:noFill/>
+          <a:ln/>
+        </p:spPr>
+        <p:txBody>
+          <a:bodyPr wrap="square" lIns="0" tIns="0" rIns="0" bIns="0" rtlCol="0" anchor="ctr"/>
+          <a:lstStyle/>
+          <a:p>
+            <a:pPr indent="0" marL="0">
+              <a:buNone/>
+            </a:pPr>
+            <a:r>
+              <a:rPr lang="en-US" sz="1100" b="1" spc="100" kern="0" dirty="0">
+                <a:solidFill>
+                  <a:srgbClr val="0A8F6E"/>
+                </a:solidFill>
+                <a:latin typeface="Calibri" pitchFamily="34" charset="0"/>
+                <a:ea typeface="Calibri" pitchFamily="34" charset="-122"/>
+                <a:cs typeface="Calibri" pitchFamily="34" charset="-120"/>
+              </a:rPr>
+              <a:t>DRAWN AT RANDOM each run</a:t>
+            </a:r>
+            <a:endParaRPr lang="en-US" sz="1100" dirty="0"/>
+          </a:p>
+        </p:txBody>
+      </p:sp>
+      <p:sp>
+        <p:nvSpPr>
+          <p:cNvPr id="10" name="Text 8"/>
+          <p:cNvSpPr/>
+          <p:nvPr/>
+        </p:nvSpPr>
+        <p:spPr>
+          <a:xfrm>
+            <a:off x="6355080" y="1874520"/>
+            <a:ext cx="5029200" cy="914400"/>
+          </a:xfrm>
+          <a:prstGeom prst="rect">
+            <a:avLst/>
+          </a:prstGeom>
+          <a:noFill/>
+          <a:ln/>
+        </p:spPr>
+        <p:txBody>
+          <a:bodyPr wrap="square" lIns="0" tIns="0" rIns="0" bIns="0" rtlCol="0" anchor="t"/>
+          <a:lstStyle/>
+          <a:p>
+            <a:pPr indent="0" marL="0">
+              <a:lnSpc>
+                <a:spcPct val="115000"/>
+              </a:lnSpc>
+              <a:buNone/>
+            </a:pPr>
+            <a:r>
+              <a:rPr lang="en-US" sz="1250" dirty="0">
+                <a:solidFill>
+                  <a:srgbClr val="27313F"/>
+                </a:solidFill>
+                <a:latin typeface="Calibri" pitchFamily="34" charset="0"/>
+                <a:ea typeface="Calibri" pitchFamily="34" charset="-122"/>
+                <a:cs typeface="Calibri" pitchFamily="34" charset="-120"/>
+              </a:rPr>
+              <a:t>Borrow rate 25-250%/yr · Utilization 20-60%</a:t>
+            </a:r>
+            <a:endParaRPr lang="en-US" sz="1250" dirty="0"/>
+          </a:p>
+          <a:p>
+            <a:pPr indent="0" marL="0">
+              <a:lnSpc>
+                <a:spcPct val="115000"/>
+              </a:lnSpc>
+              <a:buNone/>
+            </a:pPr>
+            <a:r>
+              <a:rPr lang="en-US" sz="1250" dirty="0">
+                <a:solidFill>
+                  <a:srgbClr val="27313F"/>
+                </a:solidFill>
+                <a:latin typeface="Calibri" pitchFamily="34" charset="0"/>
+                <a:ea typeface="Calibri" pitchFamily="34" charset="-122"/>
+                <a:cs typeface="Calibri" pitchFamily="34" charset="-120"/>
+              </a:rPr>
+              <a:t>Post-event fade 5-25% · Trading cost 40-150 bps</a:t>
+            </a:r>
+            <a:endParaRPr lang="en-US" sz="1250" dirty="0"/>
+          </a:p>
+          <a:p>
+            <a:pPr indent="0" marL="0">
+              <a:lnSpc>
+                <a:spcPct val="115000"/>
+              </a:lnSpc>
+              <a:buNone/>
+            </a:pPr>
+            <a:r>
+              <a:rPr lang="en-US" sz="1250" dirty="0">
+                <a:solidFill>
+                  <a:srgbClr val="27313F"/>
+                </a:solidFill>
+                <a:latin typeface="Calibri" pitchFamily="34" charset="0"/>
+                <a:ea typeface="Calibri" pitchFamily="34" charset="-122"/>
+                <a:cs typeface="Calibri" pitchFamily="34" charset="-120"/>
+              </a:rPr>
+              <a:t>(the 4 market unknowns)</a:t>
+            </a:r>
+            <a:endParaRPr lang="en-US" sz="1250" dirty="0"/>
           </a:p>
         </p:txBody>
       </p:sp>
@@ -3431,7 +3688,7 @@
           </p:nvPr>
         </p:nvGraphicFramePr>
         <p:xfrm>
-          <a:off x="548640" y="2057400"/>
+          <a:off x="548640" y="3063240"/>
           <a:ext cx="11064240" cy="914400"/>
         </p:xfrm>
         <a:graphic>
@@ -3439,12 +3696,11 @@
             <a:tbl>
               <a:tblPr/>
               <a:tblGrid>
-                <a:gridCol w="3931920"/>
-                <a:gridCol w="2377440"/>
-                <a:gridCol w="3108960"/>
-                <a:gridCol w="1645920"/>
+                <a:gridCol w="4480560"/>
+                <a:gridCol w="3291840"/>
+                <a:gridCol w="3291840"/>
               </a:tblGrid>
-              <a:tr h="548640">
+              <a:tr h="502920">
                 <a:tc>
                   <a:txBody>
                     <a:bodyPr/>
@@ -3454,7 +3710,7 @@
                         <a:buNone/>
                       </a:pPr>
                       <a:r>
-                        <a:rPr lang="en-US" sz="1250" b="1" dirty="0">
+                        <a:rPr lang="en-US" sz="1200" b="1" dirty="0">
                           <a:solidFill>
                             <a:srgbClr val="FFFFFF"/>
                           </a:solidFill>
@@ -3462,9 +3718,9 @@
                           <a:ea typeface="Calibri" pitchFamily="34" charset="-122"/>
                           <a:cs typeface="Calibri" pitchFamily="34" charset="-120"/>
                         </a:rPr>
-                        <a:t>Varied at random</a:t>
+                        <a:t>What varies (accuracy fixed)</a:t>
                       </a:r>
-                      <a:endParaRPr lang="en-US" sz="1250" dirty="0">
+                      <a:endParaRPr lang="en-US" sz="1200" dirty="0">
                         <a:latin typeface="Calibri" charset="0"/>
                         <a:ea typeface="Calibri" charset="0"/>
                         <a:cs typeface="Calibri" charset="0"/>
@@ -3522,7 +3778,7 @@
                         <a:buNone/>
                       </a:pPr>
                       <a:r>
-                        <a:rPr lang="en-US" sz="1250" b="1" dirty="0">
+                        <a:rPr lang="en-US" sz="1200" b="1" dirty="0">
                           <a:solidFill>
                             <a:srgbClr val="FFFFFF"/>
                           </a:solidFill>
@@ -3530,9 +3786,9 @@
                           <a:ea typeface="Calibri" pitchFamily="34" charset="-122"/>
                           <a:cs typeface="Calibri" pitchFamily="34" charset="-120"/>
                         </a:rPr>
-                        <a:t>Typical (median)</a:t>
+                        <a:t>90% model - precision 92%</a:t>
                       </a:r>
-                      <a:endParaRPr lang="en-US" sz="1250" dirty="0">
+                      <a:endParaRPr lang="en-US" sz="1200" dirty="0">
                         <a:latin typeface="Calibri" charset="0"/>
                         <a:ea typeface="Calibri" charset="0"/>
                         <a:cs typeface="Calibri" charset="0"/>
@@ -3590,7 +3846,7 @@
                         <a:buNone/>
                       </a:pPr>
                       <a:r>
-                        <a:rPr lang="en-US" sz="1250" b="1" dirty="0">
+                        <a:rPr lang="en-US" sz="1200" b="1" dirty="0">
                           <a:solidFill>
                             <a:srgbClr val="FFFFFF"/>
                           </a:solidFill>
@@ -3598,9 +3854,9 @@
                           <a:ea typeface="Calibri" pitchFamily="34" charset="-122"/>
                           <a:cs typeface="Calibri" pitchFamily="34" charset="-120"/>
                         </a:rPr>
-                        <a:t>90% of outcomes</a:t>
+                        <a:t>80% model - precision 84%</a:t>
                       </a:r>
-                      <a:endParaRPr lang="en-US" sz="1250" dirty="0">
+                      <a:endParaRPr lang="en-US" sz="1200" dirty="0">
                         <a:latin typeface="Calibri" charset="0"/>
                         <a:ea typeface="Calibri" charset="0"/>
                         <a:cs typeface="Calibri" charset="0"/>
@@ -3649,76 +3905,8 @@
                     </a:solidFill>
                   </a:tcPr>
                 </a:tc>
-                <a:tc>
-                  <a:txBody>
-                    <a:bodyPr/>
-                    <a:lstStyle/>
-                    <a:p>
-                      <a:pPr algn="ctr" indent="0" marL="0">
-                        <a:buNone/>
-                      </a:pPr>
-                      <a:r>
-                        <a:rPr lang="en-US" sz="1250" b="1" dirty="0">
-                          <a:solidFill>
-                            <a:srgbClr val="FFFFFF"/>
-                          </a:solidFill>
-                          <a:latin typeface="Calibri" pitchFamily="34" charset="0"/>
-                          <a:ea typeface="Calibri" pitchFamily="34" charset="-122"/>
-                          <a:cs typeface="Calibri" pitchFamily="34" charset="-120"/>
-                        </a:rPr>
-                        <a:t>Lose money?</a:t>
-                      </a:r>
-                      <a:endParaRPr lang="en-US" sz="1250" dirty="0">
-                        <a:latin typeface="Calibri" charset="0"/>
-                        <a:ea typeface="Calibri" charset="0"/>
-                        <a:cs typeface="Calibri" charset="0"/>
-                      </a:endParaRPr>
-                    </a:p>
-                  </a:txBody>
-                  <a:tcPr marL="91440" marR="91440" marT="45720" marB="45720" anchor="ctr">
-                    <a:lnL w="12700" cap="flat" cmpd="sng" algn="ctr">
-                      <a:solidFill>
-                        <a:srgbClr val="E4E6EE"/>
-                      </a:solidFill>
-                      <a:prstDash val="solid"/>
-                      <a:round/>
-                      <a:headEnd type="none" w="med" len="med"/>
-                      <a:tailEnd type="none" w="med" len="med"/>
-                    </a:lnL>
-                    <a:lnR w="12700" cap="flat" cmpd="sng" algn="ctr">
-                      <a:solidFill>
-                        <a:srgbClr val="E4E6EE"/>
-                      </a:solidFill>
-                      <a:prstDash val="solid"/>
-                      <a:round/>
-                      <a:headEnd type="none" w="med" len="med"/>
-                      <a:tailEnd type="none" w="med" len="med"/>
-                    </a:lnR>
-                    <a:lnT w="12700" cap="flat" cmpd="sng" algn="ctr">
-                      <a:solidFill>
-                        <a:srgbClr val="E4E6EE"/>
-                      </a:solidFill>
-                      <a:prstDash val="solid"/>
-                      <a:round/>
-                      <a:headEnd type="none" w="med" len="med"/>
-                      <a:tailEnd type="none" w="med" len="med"/>
-                    </a:lnT>
-                    <a:lnB w="12700" cap="flat" cmpd="sng" algn="ctr">
-                      <a:solidFill>
-                        <a:srgbClr val="E4E6EE"/>
-                      </a:solidFill>
-                      <a:prstDash val="solid"/>
-                      <a:round/>
-                      <a:headEnd type="none" w="med" len="med"/>
-                      <a:tailEnd type="none" w="med" len="med"/>
-                    </a:lnB>
-                    <a:solidFill>
-                      <a:srgbClr val="1E2761"/>
-                    </a:solidFill>
-                  </a:tcPr>
-                </a:tc>
               </a:tr>
-              <a:tr h="548640">
+              <a:tr h="502920">
                 <a:tc>
                   <a:txBody>
                     <a:bodyPr/>
@@ -3728,7 +3916,7 @@
                         <a:buNone/>
                       </a:pPr>
                       <a:r>
-                        <a:rPr lang="en-US" sz="1250" dirty="0">
+                        <a:rPr lang="en-US" sz="1200" dirty="0">
                           <a:solidFill>
                             <a:srgbClr val="27313F"/>
                           </a:solidFill>
@@ -3736,9 +3924,9 @@
                           <a:ea typeface="Calibri" pitchFamily="34" charset="-122"/>
                           <a:cs typeface="Calibri" pitchFamily="34" charset="-120"/>
                         </a:rPr>
-                        <a:t>Borrow rate, utilization,</a:t>
+                        <a:t>Assumptions drawn independently</a:t>
                       </a:r>
-                      <a:endParaRPr lang="en-US" sz="1250" dirty="0">
+                      <a:endParaRPr lang="en-US" sz="1200" dirty="0">
                         <a:latin typeface="Calibri" charset="0"/>
                         <a:ea typeface="Calibri" charset="0"/>
                         <a:cs typeface="Calibri" charset="0"/>
@@ -3793,17 +3981,17 @@
                         <a:buNone/>
                       </a:pPr>
                       <a:r>
-                        <a:rPr lang="en-US" sz="1250" b="1" dirty="0">
+                        <a:rPr lang="en-US" sz="1200" dirty="0">
                           <a:solidFill>
-                            <a:srgbClr val="02C39A"/>
+                            <a:srgbClr val="27313F"/>
                           </a:solidFill>
                           <a:latin typeface="Calibri" pitchFamily="34" charset="0"/>
                           <a:ea typeface="Calibri" pitchFamily="34" charset="-122"/>
                           <a:cs typeface="Calibri" pitchFamily="34" charset="-120"/>
                         </a:rPr>
-                        <a:t>$22M</a:t>
+                        <a:t>$21.9M  [18.0, 27.8]</a:t>
                       </a:r>
-                      <a:endParaRPr lang="en-US" sz="1250" dirty="0">
+                      <a:endParaRPr lang="en-US" sz="1200" dirty="0">
                         <a:latin typeface="Calibri" charset="0"/>
                         <a:ea typeface="Calibri" charset="0"/>
                         <a:cs typeface="Calibri" charset="0"/>
@@ -3858,7 +4046,7 @@
                         <a:buNone/>
                       </a:pPr>
                       <a:r>
-                        <a:rPr lang="en-US" sz="1250" dirty="0">
+                        <a:rPr lang="en-US" sz="1200" dirty="0">
                           <a:solidFill>
                             <a:srgbClr val="27313F"/>
                           </a:solidFill>
@@ -3866,9 +4054,76 @@
                           <a:ea typeface="Calibri" pitchFamily="34" charset="-122"/>
                           <a:cs typeface="Calibri" pitchFamily="34" charset="-120"/>
                         </a:rPr>
-                        <a:t>$18M - $27M</a:t>
+                        <a:t>$19.8M  [15.7, 25.6]</a:t>
                       </a:r>
-                      <a:endParaRPr lang="en-US" sz="1250" dirty="0">
+                      <a:endParaRPr lang="en-US" sz="1200" dirty="0">
+                        <a:latin typeface="Calibri" charset="0"/>
+                        <a:ea typeface="Calibri" charset="0"/>
+                        <a:cs typeface="Calibri" charset="0"/>
+                      </a:endParaRPr>
+                    </a:p>
+                  </a:txBody>
+                  <a:tcPr marL="91440" marR="91440" marT="45720" marB="45720" anchor="ctr">
+                    <a:lnL w="12700" cap="flat" cmpd="sng" algn="ctr">
+                      <a:solidFill>
+                        <a:srgbClr val="E4E6EE"/>
+                      </a:solidFill>
+                      <a:prstDash val="solid"/>
+                      <a:round/>
+                      <a:headEnd type="none" w="med" len="med"/>
+                      <a:tailEnd type="none" w="med" len="med"/>
+                    </a:lnL>
+                    <a:lnR w="12700" cap="flat" cmpd="sng" algn="ctr">
+                      <a:solidFill>
+                        <a:srgbClr val="E4E6EE"/>
+                      </a:solidFill>
+                      <a:prstDash val="solid"/>
+                      <a:round/>
+                      <a:headEnd type="none" w="med" len="med"/>
+                      <a:tailEnd type="none" w="med" len="med"/>
+                    </a:lnR>
+                    <a:lnT w="12700" cap="flat" cmpd="sng" algn="ctr">
+                      <a:solidFill>
+                        <a:srgbClr val="E4E6EE"/>
+                      </a:solidFill>
+                      <a:prstDash val="solid"/>
+                      <a:round/>
+                      <a:headEnd type="none" w="med" len="med"/>
+                      <a:tailEnd type="none" w="med" len="med"/>
+                    </a:lnT>
+                    <a:lnB w="12700" cap="flat" cmpd="sng" algn="ctr">
+                      <a:solidFill>
+                        <a:srgbClr val="E4E6EE"/>
+                      </a:solidFill>
+                      <a:prstDash val="solid"/>
+                      <a:round/>
+                      <a:headEnd type="none" w="med" len="med"/>
+                      <a:tailEnd type="none" w="med" len="med"/>
+                    </a:lnB>
+                  </a:tcPr>
+                </a:tc>
+              </a:tr>
+              <a:tr h="502920">
+                <a:tc>
+                  <a:txBody>
+                    <a:bodyPr/>
+                    <a:lstStyle/>
+                    <a:p>
+                      <a:pPr algn="l" indent="0" marL="0">
+                        <a:buNone/>
+                      </a:pPr>
+                      <a:r>
+                        <a:rPr lang="en-US" sz="1200" b="1" dirty="0">
+                          <a:solidFill>
+                            <a:srgbClr val="1E2761"/>
+                          </a:solidFill>
+                          <a:latin typeface="Calibri" pitchFamily="34" charset="0"/>
+                          <a:ea typeface="Calibri" pitchFamily="34" charset="-122"/>
+                          <a:cs typeface="Calibri" pitchFamily="34" charset="-120"/>
+                        </a:rPr>
+                        <a:t>Assumptions correlated (all hit at once)</a:t>
+                      </a:r>
+                      <a:endParaRPr lang="en-US" sz="1200" dirty="0">
                         <a:latin typeface="Calibri" charset="0"/>
                         <a:ea typeface="Calibri" charset="0"/>
                         <a:cs typeface="Calibri" charset="0"/>
@@ -3923,84 +4178,17 @@
                         <a:buNone/>
                       </a:pPr>
                       <a:r>
-                        <a:rPr lang="en-US" sz="1250" b="1" dirty="0">
+                        <a:rPr lang="en-US" sz="1200" b="1" dirty="0">
                           <a:solidFill>
-                            <a:srgbClr val="02C39A"/>
+                            <a:srgbClr val="27313F"/>
                           </a:solidFill>
                           <a:latin typeface="Calibri" pitchFamily="34" charset="0"/>
                           <a:ea typeface="Calibri" pitchFamily="34" charset="-122"/>
                           <a:cs typeface="Calibri" pitchFamily="34" charset="-120"/>
                         </a:rPr>
-                        <a:t>0%</a:t>
+                        <a:t>$21.7M  [18.4, 26.6]</a:t>
                       </a:r>
-                      <a:endParaRPr lang="en-US" sz="1250" dirty="0">
-                        <a:latin typeface="Calibri" charset="0"/>
-                        <a:ea typeface="Calibri" charset="0"/>
-                        <a:cs typeface="Calibri" charset="0"/>
-                      </a:endParaRPr>
-                    </a:p>
-                  </a:txBody>
-                  <a:tcPr marL="91440" marR="91440" marT="45720" marB="45720" anchor="ctr">
-                    <a:lnL w="12700" cap="flat" cmpd="sng" algn="ctr">
-                      <a:solidFill>
-                        <a:srgbClr val="E4E6EE"/>
-                      </a:solidFill>
-                      <a:prstDash val="solid"/>
-                      <a:round/>
-                      <a:headEnd type="none" w="med" len="med"/>
-                      <a:tailEnd type="none" w="med" len="med"/>
-                    </a:lnL>
-                    <a:lnR w="12700" cap="flat" cmpd="sng" algn="ctr">
-                      <a:solidFill>
-                        <a:srgbClr val="E4E6EE"/>
-                      </a:solidFill>
-                      <a:prstDash val="solid"/>
-                      <a:round/>
-                      <a:headEnd type="none" w="med" len="med"/>
-                      <a:tailEnd type="none" w="med" len="med"/>
-                    </a:lnR>
-                    <a:lnT w="12700" cap="flat" cmpd="sng" algn="ctr">
-                      <a:solidFill>
-                        <a:srgbClr val="E4E6EE"/>
-                      </a:solidFill>
-                      <a:prstDash val="solid"/>
-                      <a:round/>
-                      <a:headEnd type="none" w="med" len="med"/>
-                      <a:tailEnd type="none" w="med" len="med"/>
-                    </a:lnT>
-                    <a:lnB w="12700" cap="flat" cmpd="sng" algn="ctr">
-                      <a:solidFill>
-                        <a:srgbClr val="E4E6EE"/>
-                      </a:solidFill>
-                      <a:prstDash val="solid"/>
-                      <a:round/>
-                      <a:headEnd type="none" w="med" len="med"/>
-                      <a:tailEnd type="none" w="med" len="med"/>
-                    </a:lnB>
-                  </a:tcPr>
-                </a:tc>
-              </a:tr>
-              <a:tr h="548640">
-                <a:tc>
-                  <a:txBody>
-                    <a:bodyPr/>
-                    <a:lstStyle/>
-                    <a:p>
-                      <a:pPr algn="l" indent="0" marL="0">
-                        <a:buNone/>
-                      </a:pPr>
-                      <a:r>
-                        <a:rPr lang="en-US" sz="1250" dirty="0">
-                          <a:solidFill>
-                            <a:srgbClr val="5B636E"/>
-                          </a:solidFill>
-                          <a:latin typeface="Calibri" pitchFamily="34" charset="0"/>
-                          <a:ea typeface="Calibri" pitchFamily="34" charset="-122"/>
-                          <a:cs typeface="Calibri" pitchFamily="34" charset="-120"/>
-                        </a:rPr>
-                        <a:t>post-event fade, trading cost</a:t>
-                      </a:r>
-                      <a:endParaRPr lang="en-US" sz="1250" dirty="0">
+                      <a:endParaRPr lang="en-US" sz="1200" dirty="0">
                         <a:latin typeface="Calibri" charset="0"/>
                         <a:ea typeface="Calibri" charset="0"/>
                         <a:cs typeface="Calibri" charset="0"/>
@@ -4055,7 +4243,7 @@
                         <a:buNone/>
                       </a:pPr>
                       <a:r>
-                        <a:rPr lang="en-US" sz="1250" dirty="0">
+                        <a:rPr lang="en-US" sz="1200" b="1" dirty="0">
                           <a:solidFill>
                             <a:srgbClr val="27313F"/>
                           </a:solidFill>
@@ -4063,9 +4251,76 @@
                           <a:ea typeface="Calibri" pitchFamily="34" charset="-122"/>
                           <a:cs typeface="Calibri" pitchFamily="34" charset="-120"/>
                         </a:rPr>
-                        <a:t>22% / yr</a:t>
+                        <a:t>$19.5M  [15.4, 24.3]</a:t>
                       </a:r>
-                      <a:endParaRPr lang="en-US" sz="1250" dirty="0">
+                      <a:endParaRPr lang="en-US" sz="1200" dirty="0">
+                        <a:latin typeface="Calibri" charset="0"/>
+                        <a:ea typeface="Calibri" charset="0"/>
+                        <a:cs typeface="Calibri" charset="0"/>
+                      </a:endParaRPr>
+                    </a:p>
+                  </a:txBody>
+                  <a:tcPr marL="91440" marR="91440" marT="45720" marB="45720" anchor="ctr">
+                    <a:lnL w="12700" cap="flat" cmpd="sng" algn="ctr">
+                      <a:solidFill>
+                        <a:srgbClr val="E4E6EE"/>
+                      </a:solidFill>
+                      <a:prstDash val="solid"/>
+                      <a:round/>
+                      <a:headEnd type="none" w="med" len="med"/>
+                      <a:tailEnd type="none" w="med" len="med"/>
+                    </a:lnL>
+                    <a:lnR w="12700" cap="flat" cmpd="sng" algn="ctr">
+                      <a:solidFill>
+                        <a:srgbClr val="E4E6EE"/>
+                      </a:solidFill>
+                      <a:prstDash val="solid"/>
+                      <a:round/>
+                      <a:headEnd type="none" w="med" len="med"/>
+                      <a:tailEnd type="none" w="med" len="med"/>
+                    </a:lnR>
+                    <a:lnT w="12700" cap="flat" cmpd="sng" algn="ctr">
+                      <a:solidFill>
+                        <a:srgbClr val="E4E6EE"/>
+                      </a:solidFill>
+                      <a:prstDash val="solid"/>
+                      <a:round/>
+                      <a:headEnd type="none" w="med" len="med"/>
+                      <a:tailEnd type="none" w="med" len="med"/>
+                    </a:lnT>
+                    <a:lnB w="12700" cap="flat" cmpd="sng" algn="ctr">
+                      <a:solidFill>
+                        <a:srgbClr val="E4E6EE"/>
+                      </a:solidFill>
+                      <a:prstDash val="solid"/>
+                      <a:round/>
+                      <a:headEnd type="none" w="med" len="med"/>
+                      <a:tailEnd type="none" w="med" len="med"/>
+                    </a:lnB>
+                  </a:tcPr>
+                </a:tc>
+              </a:tr>
+              <a:tr h="502920">
+                <a:tc>
+                  <a:txBody>
+                    <a:bodyPr/>
+                    <a:lstStyle/>
+                    <a:p>
+                      <a:pPr algn="l" indent="0" marL="0">
+                        <a:buNone/>
+                      </a:pPr>
+                      <a:r>
+                        <a:rPr lang="en-US" sz="1200" i="1" dirty="0">
+                          <a:solidFill>
+                            <a:srgbClr val="27313F"/>
+                          </a:solidFill>
+                          <a:latin typeface="Calibri" pitchFamily="34" charset="0"/>
+                          <a:ea typeface="Calibri" pitchFamily="34" charset="-122"/>
+                          <a:cs typeface="Calibri" pitchFamily="34" charset="-120"/>
+                        </a:rPr>
+                        <a:t>Chance of losing money (in the sims)</a:t>
+                      </a:r>
+                      <a:endParaRPr lang="en-US" sz="1200" dirty="0">
                         <a:latin typeface="Calibri" charset="0"/>
                         <a:ea typeface="Calibri" charset="0"/>
                         <a:cs typeface="Calibri" charset="0"/>
@@ -4120,17 +4375,17 @@
                         <a:buNone/>
                       </a:pPr>
                       <a:r>
-                        <a:rPr lang="en-US" sz="1250" dirty="0">
+                        <a:rPr lang="en-US" sz="1200" b="1" dirty="0">
                           <a:solidFill>
-                            <a:srgbClr val="27313F"/>
+                            <a:srgbClr val="02C39A"/>
                           </a:solidFill>
                           <a:latin typeface="Calibri" pitchFamily="34" charset="0"/>
                           <a:ea typeface="Calibri" pitchFamily="34" charset="-122"/>
                           <a:cs typeface="Calibri" pitchFamily="34" charset="-120"/>
                         </a:rPr>
-                        <a:t>(never below $10M start)</a:t>
+                        <a:t>0%</a:t>
                       </a:r>
-                      <a:endParaRPr lang="en-US" sz="1250" dirty="0">
+                      <a:endParaRPr lang="en-US" sz="1200" dirty="0">
                         <a:latin typeface="Calibri" charset="0"/>
                         <a:ea typeface="Calibri" charset="0"/>
                         <a:cs typeface="Calibri" charset="0"/>
@@ -4185,17 +4440,17 @@
                         <a:buNone/>
                       </a:pPr>
                       <a:r>
-                        <a:rPr lang="en-US" sz="1250" dirty="0">
+                        <a:rPr lang="en-US" sz="1200" b="1" dirty="0">
                           <a:solidFill>
-                            <a:srgbClr val="5B636E"/>
+                            <a:srgbClr val="02C39A"/>
                           </a:solidFill>
                           <a:latin typeface="Calibri" pitchFamily="34" charset="0"/>
                           <a:ea typeface="Calibri" pitchFamily="34" charset="-122"/>
                           <a:cs typeface="Calibri" pitchFamily="34" charset="-120"/>
                         </a:rPr>
-                        <a:t>in the sims</a:t>
+                        <a:t>0%</a:t>
                       </a:r>
-                      <a:endParaRPr lang="en-US" sz="1250" dirty="0">
+                      <a:endParaRPr lang="en-US" sz="1200" dirty="0">
                         <a:latin typeface="Calibri" charset="0"/>
                         <a:ea typeface="Calibri" charset="0"/>
                         <a:cs typeface="Calibri" charset="0"/>
@@ -4248,201 +4503,50 @@
       </p:graphicFrame>
       <p:sp>
         <p:nvSpPr>
-          <p:cNvPr id="7" name="Shape 4"/>
-          <p:cNvSpPr/>
-          <p:nvPr/>
-        </p:nvSpPr>
-        <p:spPr>
-          <a:xfrm>
-            <a:off x="548640" y="3657600"/>
-            <a:ext cx="5394960" cy="1554480"/>
-          </a:xfrm>
-          <a:prstGeom prst="roundRect">
-            <a:avLst>
-              <a:gd name="adj" fmla="val 4706"/>
-            </a:avLst>
-          </a:prstGeom>
-          <a:solidFill>
-            <a:srgbClr val="F0FAF6"/>
-          </a:solidFill>
-          <a:ln w="12700">
-            <a:solidFill>
-              <a:srgbClr val="02C39A"/>
-            </a:solidFill>
-            <a:prstDash val="solid"/>
-          </a:ln>
-        </p:spPr>
-      </p:sp>
-      <p:sp>
-        <p:nvSpPr>
-          <p:cNvPr id="8" name="Text 5"/>
-          <p:cNvSpPr/>
-          <p:nvPr/>
-        </p:nvSpPr>
-        <p:spPr>
-          <a:xfrm>
-            <a:off x="777240" y="3767328"/>
-            <a:ext cx="4937760" cy="274320"/>
-          </a:xfrm>
-          <a:prstGeom prst="rect">
-            <a:avLst/>
-          </a:prstGeom>
-          <a:noFill/>
-          <a:ln/>
-        </p:spPr>
-        <p:txBody>
-          <a:bodyPr wrap="square" lIns="0" tIns="0" rIns="0" bIns="0" rtlCol="0" anchor="ctr"/>
+          <p:cNvPr id="12" name="Text 9"/>
+          <p:cNvSpPr/>
+          <p:nvPr/>
+        </p:nvSpPr>
+        <p:spPr>
+          <a:xfrm>
+            <a:off x="548640" y="5257800"/>
+            <a:ext cx="11064240" cy="777240"/>
+          </a:xfrm>
+          <a:prstGeom prst="rect">
+            <a:avLst/>
+          </a:prstGeom>
+          <a:noFill/>
+          <a:ln/>
+        </p:spPr>
+        <p:txBody>
+          <a:bodyPr wrap="square" rtlCol="0" anchor="t"/>
           <a:lstStyle/>
           <a:p>
             <a:pPr indent="0" marL="0">
-              <a:buNone/>
-            </a:pPr>
-            <a:r>
-              <a:rPr lang="en-US" sz="1400" b="1" dirty="0">
-                <a:solidFill>
-                  <a:srgbClr val="02C39A"/>
-                </a:solidFill>
-                <a:latin typeface="Cambria" pitchFamily="34" charset="0"/>
-                <a:ea typeface="Cambria" pitchFamily="34" charset="-122"/>
-                <a:cs typeface="Cambria" pitchFamily="34" charset="-120"/>
-              </a:rPr>
-              <a:t>The good news</a:t>
-            </a:r>
-            <a:endParaRPr lang="en-US" sz="1400" dirty="0"/>
-          </a:p>
-        </p:txBody>
-      </p:sp>
-      <p:sp>
-        <p:nvSpPr>
-          <p:cNvPr id="9" name="Text 6"/>
-          <p:cNvSpPr/>
-          <p:nvPr/>
-        </p:nvSpPr>
-        <p:spPr>
-          <a:xfrm>
-            <a:off x="777240" y="4096512"/>
-            <a:ext cx="4937760" cy="1005840"/>
-          </a:xfrm>
-          <a:prstGeom prst="rect">
-            <a:avLst/>
-          </a:prstGeom>
-          <a:noFill/>
-          <a:ln/>
-        </p:spPr>
-        <p:txBody>
-          <a:bodyPr wrap="square" lIns="0" tIns="0" rIns="0" bIns="0" rtlCol="0" anchor="t"/>
-          <a:lstStyle/>
-          <a:p>
-            <a:pPr indent="0" marL="0">
-              <a:buNone/>
-            </a:pPr>
-            <a:r>
-              <a:rPr lang="en-US" sz="1250" dirty="0">
-                <a:solidFill>
-                  <a:srgbClr val="27313F"/>
+              <a:lnSpc>
+                <a:spcPct val="115000"/>
+              </a:lnSpc>
+              <a:buNone/>
+            </a:pPr>
+            <a:r>
+              <a:rPr lang="en-US" sz="1300" b="1" dirty="0">
+                <a:solidFill>
+                  <a:srgbClr val="1E2761"/>
                 </a:solidFill>
                 <a:latin typeface="Calibri" pitchFamily="34" charset="0"/>
                 <a:ea typeface="Calibri" pitchFamily="34" charset="-122"/>
                 <a:cs typeface="Calibri" pitchFamily="34" charset="-120"/>
               </a:rPr>
-              <a:t>Even in the unlucky 5% of runs it still ends around $18M - well above the $10M we started with. The cost assumptions don't make or break it.</a:t>
-            </a:r>
-            <a:endParaRPr lang="en-US" sz="1250" dirty="0"/>
-          </a:p>
-        </p:txBody>
-      </p:sp>
-      <p:sp>
-        <p:nvSpPr>
-          <p:cNvPr id="10" name="Shape 7"/>
-          <p:cNvSpPr/>
-          <p:nvPr/>
-        </p:nvSpPr>
-        <p:spPr>
-          <a:xfrm>
-            <a:off x="6172200" y="3657600"/>
-            <a:ext cx="5440680" cy="1554480"/>
-          </a:xfrm>
-          <a:prstGeom prst="roundRect">
-            <a:avLst>
-              <a:gd name="adj" fmla="val 4706"/>
-            </a:avLst>
-          </a:prstGeom>
-          <a:solidFill>
-            <a:srgbClr val="FBF7EE"/>
-          </a:solidFill>
-          <a:ln w="12700">
-            <a:solidFill>
-              <a:srgbClr val="E0A458"/>
-            </a:solidFill>
-            <a:prstDash val="solid"/>
-          </a:ln>
-        </p:spPr>
-      </p:sp>
-      <p:sp>
-        <p:nvSpPr>
-          <p:cNvPr id="11" name="Text 8"/>
-          <p:cNvSpPr/>
-          <p:nvPr/>
-        </p:nvSpPr>
-        <p:spPr>
-          <a:xfrm>
-            <a:off x="6400800" y="3767328"/>
-            <a:ext cx="5029200" cy="274320"/>
-          </a:xfrm>
-          <a:prstGeom prst="rect">
-            <a:avLst/>
-          </a:prstGeom>
-          <a:noFill/>
-          <a:ln/>
-        </p:spPr>
-        <p:txBody>
-          <a:bodyPr wrap="square" lIns="0" tIns="0" rIns="0" bIns="0" rtlCol="0" anchor="ctr"/>
-          <a:lstStyle/>
-          <a:p>
+              <a:t>Read: </a:t>
+            </a:r>
             <a:pPr indent="0" marL="0">
-              <a:buNone/>
-            </a:pPr>
-            <a:r>
-              <a:rPr lang="en-US" sz="1400" b="1" dirty="0">
-                <a:solidFill>
-                  <a:srgbClr val="9A6A12"/>
-                </a:solidFill>
-                <a:latin typeface="Cambria" pitchFamily="34" charset="0"/>
-                <a:ea typeface="Cambria" pitchFamily="34" charset="-122"/>
-                <a:cs typeface="Cambria" pitchFamily="34" charset="-120"/>
-              </a:rPr>
-              <a:t>The catch</a:t>
-            </a:r>
-            <a:endParaRPr lang="en-US" sz="1400" dirty="0"/>
-          </a:p>
-        </p:txBody>
-      </p:sp>
-      <p:sp>
-        <p:nvSpPr>
-          <p:cNvPr id="12" name="Text 9"/>
-          <p:cNvSpPr/>
-          <p:nvPr/>
-        </p:nvSpPr>
-        <p:spPr>
-          <a:xfrm>
-            <a:off x="6400800" y="4096512"/>
-            <a:ext cx="5029200" cy="1051560"/>
-          </a:xfrm>
-          <a:prstGeom prst="rect">
-            <a:avLst/>
-          </a:prstGeom>
-          <a:noFill/>
-          <a:ln/>
-        </p:spPr>
-        <p:txBody>
-          <a:bodyPr wrap="square" lIns="0" tIns="0" rIns="0" bIns="0" rtlCol="0" anchor="t"/>
-          <a:lstStyle/>
-          <a:p>
-            <a:pPr indent="0" marL="0">
-              <a:buNone/>
-            </a:pPr>
-            <a:r>
-              <a:rPr lang="en-US" sz="1250" dirty="0">
+              <a:lnSpc>
+                <a:spcPct val="115000"/>
+              </a:lnSpc>
+              <a:buNone/>
+            </a:pPr>
+            <a:r>
+              <a:rPr lang="en-US" sz="1300" dirty="0">
                 <a:solidFill>
                   <a:srgbClr val="27313F"/>
                 </a:solidFill>
@@ -4450,15 +4554,71 @@
                 <a:ea typeface="Calibri" pitchFamily="34" charset="-122"/>
                 <a:cs typeface="Calibri" pitchFamily="34" charset="-120"/>
               </a:rPr>
-              <a:t>This only shuffles the cost guesses, not the market. Every run uses 2016-2019 prices - so "0% lose" means in a market like that one. Model accuracy is tested separately (next slide).</a:t>
-            </a:r>
-            <a:endParaRPr lang="en-US" sz="1250" dirty="0"/>
+              <a:t>a typical run makes ~$22M; even the unlucky 5% stays ~$18M, above the $10M start. Correlating the assumptions (a stress regime hits all at once) barely trims it. So the cost guesses don't break it. </a:t>
+            </a:r>
+            <a:pPr indent="0" marL="0">
+              <a:lnSpc>
+                <a:spcPct val="115000"/>
+              </a:lnSpc>
+              <a:buNone/>
+            </a:pPr>
+            <a:r>
+              <a:rPr lang="en-US" sz="1300" b="1" dirty="0">
+                <a:solidFill>
+                  <a:srgbClr val="9A6A12"/>
+                </a:solidFill>
+                <a:latin typeface="Calibri" pitchFamily="34" charset="0"/>
+                <a:ea typeface="Calibri" pitchFamily="34" charset="-122"/>
+                <a:cs typeface="Calibri" pitchFamily="34" charset="-120"/>
+              </a:rPr>
+              <a:t>Caveat: every run uses 2016-2019 prices, so "0% loss" means in a market like that one.</a:t>
+            </a:r>
+            <a:endParaRPr lang="en-US" sz="1300" dirty="0"/>
           </a:p>
         </p:txBody>
       </p:sp>
       <p:sp>
         <p:nvSpPr>
           <p:cNvPr id="13" name="Text 10"/>
+          <p:cNvSpPr/>
+          <p:nvPr/>
+        </p:nvSpPr>
+        <p:spPr>
+          <a:xfrm>
+            <a:off x="548640" y="6108192"/>
+            <a:ext cx="11064240" cy="320040"/>
+          </a:xfrm>
+          <a:prstGeom prst="rect">
+            <a:avLst/>
+          </a:prstGeom>
+          <a:noFill/>
+          <a:ln/>
+        </p:spPr>
+        <p:txBody>
+          <a:bodyPr wrap="square" rtlCol="0" anchor="ctr"/>
+          <a:lstStyle/>
+          <a:p>
+            <a:pPr indent="0" marL="0">
+              <a:buNone/>
+            </a:pPr>
+            <a:r>
+              <a:rPr lang="en-US" sz="1100" i="1" dirty="0">
+                <a:solidFill>
+                  <a:srgbClr val="5B636E"/>
+                </a:solidFill>
+                <a:latin typeface="Calibri" pitchFamily="34" charset="0"/>
+                <a:ea typeface="Calibri" pitchFamily="34" charset="-122"/>
+                <a:cs typeface="Calibri" pitchFamily="34" charset="-120"/>
+              </a:rPr>
+              <a:t>Precision (in the header) = when the model says "success," how often it's right; 92% here because we're at the realistic 56% base rate (next slide).</a:t>
+            </a:r>
+            <a:endParaRPr lang="en-US" sz="1100" dirty="0"/>
+          </a:p>
+        </p:txBody>
+      </p:sp>
+      <p:sp>
+        <p:nvSpPr>
+          <p:cNvPr id="14" name="Text 11"/>
           <p:cNvSpPr/>
           <p:nvPr/>
         </p:nvSpPr>

</xml_diff>